<commit_message>
Correct binary translation for signed 16bit integers
</commit_message>
<xml_diff>
--- a/figures/resources/data_types.pptx
+++ b/figures/resources/data_types.pptx
@@ -201,7 +201,7 @@
           <a:p>
             <a:fld id="{922FCDE8-9265-274C-B63C-E407950C8DE1}" type="datetimeFigureOut">
               <a:rPr lang="de-DE" smtClean="0"/>
-              <a:t>25.06.26</a:t>
+              <a:t>29.10.26</a:t>
             </a:fld>
             <a:endParaRPr lang="de-DE"/>
           </a:p>
@@ -984,7 +984,7 @@
           <a:p>
             <a:fld id="{747B7DA0-53A4-8447-B8D4-5B08E7A75C15}" type="datetimeFigureOut">
               <a:rPr lang="de-DE" smtClean="0"/>
-              <a:t>25.06.26</a:t>
+              <a:t>29.10.26</a:t>
             </a:fld>
             <a:endParaRPr lang="de-DE"/>
           </a:p>
@@ -1184,7 +1184,7 @@
           <a:p>
             <a:fld id="{747B7DA0-53A4-8447-B8D4-5B08E7A75C15}" type="datetimeFigureOut">
               <a:rPr lang="de-DE" smtClean="0"/>
-              <a:t>25.06.26</a:t>
+              <a:t>29.10.26</a:t>
             </a:fld>
             <a:endParaRPr lang="de-DE"/>
           </a:p>
@@ -1394,7 +1394,7 @@
           <a:p>
             <a:fld id="{747B7DA0-53A4-8447-B8D4-5B08E7A75C15}" type="datetimeFigureOut">
               <a:rPr lang="de-DE" smtClean="0"/>
-              <a:t>25.06.26</a:t>
+              <a:t>29.10.26</a:t>
             </a:fld>
             <a:endParaRPr lang="de-DE"/>
           </a:p>
@@ -2204,7 +2204,7 @@
           <a:p>
             <a:fld id="{747B7DA0-53A4-8447-B8D4-5B08E7A75C15}" type="datetimeFigureOut">
               <a:rPr lang="de-DE" smtClean="0"/>
-              <a:t>25.06.26</a:t>
+              <a:t>29.10.26</a:t>
             </a:fld>
             <a:endParaRPr lang="de-DE"/>
           </a:p>
@@ -2480,7 +2480,7 @@
           <a:p>
             <a:fld id="{747B7DA0-53A4-8447-B8D4-5B08E7A75C15}" type="datetimeFigureOut">
               <a:rPr lang="de-DE" smtClean="0"/>
-              <a:t>25.06.26</a:t>
+              <a:t>29.10.26</a:t>
             </a:fld>
             <a:endParaRPr lang="de-DE"/>
           </a:p>
@@ -2748,7 +2748,7 @@
           <a:p>
             <a:fld id="{747B7DA0-53A4-8447-B8D4-5B08E7A75C15}" type="datetimeFigureOut">
               <a:rPr lang="de-DE" smtClean="0"/>
-              <a:t>25.06.26</a:t>
+              <a:t>29.10.26</a:t>
             </a:fld>
             <a:endParaRPr lang="de-DE"/>
           </a:p>
@@ -3163,7 +3163,7 @@
           <a:p>
             <a:fld id="{747B7DA0-53A4-8447-B8D4-5B08E7A75C15}" type="datetimeFigureOut">
               <a:rPr lang="de-DE" smtClean="0"/>
-              <a:t>25.06.26</a:t>
+              <a:t>29.10.26</a:t>
             </a:fld>
             <a:endParaRPr lang="de-DE"/>
           </a:p>
@@ -3305,7 +3305,7 @@
           <a:p>
             <a:fld id="{747B7DA0-53A4-8447-B8D4-5B08E7A75C15}" type="datetimeFigureOut">
               <a:rPr lang="de-DE" smtClean="0"/>
-              <a:t>25.06.26</a:t>
+              <a:t>29.10.26</a:t>
             </a:fld>
             <a:endParaRPr lang="de-DE"/>
           </a:p>
@@ -3418,7 +3418,7 @@
           <a:p>
             <a:fld id="{747B7DA0-53A4-8447-B8D4-5B08E7A75C15}" type="datetimeFigureOut">
               <a:rPr lang="de-DE" smtClean="0"/>
-              <a:t>25.06.26</a:t>
+              <a:t>29.10.26</a:t>
             </a:fld>
             <a:endParaRPr lang="de-DE"/>
           </a:p>
@@ -3731,7 +3731,7 @@
           <a:p>
             <a:fld id="{747B7DA0-53A4-8447-B8D4-5B08E7A75C15}" type="datetimeFigureOut">
               <a:rPr lang="de-DE" smtClean="0"/>
-              <a:t>25.06.26</a:t>
+              <a:t>29.10.26</a:t>
             </a:fld>
             <a:endParaRPr lang="de-DE"/>
           </a:p>
@@ -4020,7 +4020,7 @@
           <a:p>
             <a:fld id="{747B7DA0-53A4-8447-B8D4-5B08E7A75C15}" type="datetimeFigureOut">
               <a:rPr lang="de-DE" smtClean="0"/>
-              <a:t>25.06.26</a:t>
+              <a:t>29.10.26</a:t>
             </a:fld>
             <a:endParaRPr lang="de-DE"/>
           </a:p>
@@ -4263,7 +4263,7 @@
           <a:p>
             <a:fld id="{747B7DA0-53A4-8447-B8D4-5B08E7A75C15}" type="datetimeFigureOut">
               <a:rPr lang="de-DE" smtClean="0"/>
-              <a:t>25.06.26</a:t>
+              <a:t>29.10.26</a:t>
             </a:fld>
             <a:endParaRPr lang="de-DE"/>
           </a:p>
@@ -5047,10 +5047,17 @@
                 <a:latin typeface="Courier New" panose="02070309020205020404" pitchFamily="49" charset="0"/>
                 <a:cs typeface="Courier New" panose="02070309020205020404" pitchFamily="49" charset="0"/>
               </a:rPr>
-              <a:t>000000000000000 = </a:t>
-            </a:r>
-            <a:r>
-              <a:rPr lang="de-DE" dirty="0">
+              <a:t>000000000000000 </a:t>
+            </a:r>
+            <a:r>
+              <a:rPr lang="de-DE">
+                <a:latin typeface="Courier New" panose="02070309020205020404" pitchFamily="49" charset="0"/>
+                <a:cs typeface="Courier New" panose="02070309020205020404" pitchFamily="49" charset="0"/>
+              </a:rPr>
+              <a:t>= </a:t>
+            </a:r>
+            <a:r>
+              <a:rPr lang="de-DE">
                 <a:solidFill>
                   <a:schemeClr val="accent2"/>
                 </a:solidFill>
@@ -5060,12 +5067,16 @@
               <a:t>-</a:t>
             </a:r>
             <a:r>
-              <a:rPr lang="de-DE" dirty="0">
-                <a:latin typeface="Courier New" panose="02070309020205020404" pitchFamily="49" charset="0"/>
-                <a:cs typeface="Courier New" panose="02070309020205020404" pitchFamily="49" charset="0"/>
-              </a:rPr>
-              <a:t>65536</a:t>
-            </a:r>
+              <a:rPr lang="de-DE">
+                <a:latin typeface="Courier New" panose="02070309020205020404" pitchFamily="49" charset="0"/>
+                <a:cs typeface="Courier New" panose="02070309020205020404" pitchFamily="49" charset="0"/>
+              </a:rPr>
+              <a:t>32768</a:t>
+            </a:r>
+            <a:endParaRPr lang="de-DE" dirty="0">
+              <a:latin typeface="Courier New" panose="02070309020205020404" pitchFamily="49" charset="0"/>
+              <a:cs typeface="Courier New" panose="02070309020205020404" pitchFamily="49" charset="0"/>
+            </a:endParaRPr>
           </a:p>
           <a:p>
             <a:r>
@@ -5083,10 +5094,17 @@
                 <a:latin typeface="Courier New" panose="02070309020205020404" pitchFamily="49" charset="0"/>
                 <a:cs typeface="Courier New" panose="02070309020205020404" pitchFamily="49" charset="0"/>
               </a:rPr>
-              <a:t>000000000000100 = </a:t>
-            </a:r>
-            <a:r>
-              <a:rPr lang="de-DE" dirty="0">
+              <a:t>000000000000100 </a:t>
+            </a:r>
+            <a:r>
+              <a:rPr lang="de-DE">
+                <a:latin typeface="Courier New" panose="02070309020205020404" pitchFamily="49" charset="0"/>
+                <a:cs typeface="Courier New" panose="02070309020205020404" pitchFamily="49" charset="0"/>
+              </a:rPr>
+              <a:t>= </a:t>
+            </a:r>
+            <a:r>
+              <a:rPr lang="de-DE">
                 <a:solidFill>
                   <a:schemeClr val="accent2"/>
                 </a:solidFill>
@@ -5096,12 +5114,16 @@
               <a:t>-</a:t>
             </a:r>
             <a:r>
-              <a:rPr lang="de-DE" dirty="0">
-                <a:latin typeface="Courier New" panose="02070309020205020404" pitchFamily="49" charset="0"/>
-                <a:cs typeface="Courier New" panose="02070309020205020404" pitchFamily="49" charset="0"/>
-              </a:rPr>
-              <a:t>65532</a:t>
-            </a:r>
+              <a:rPr lang="de-DE">
+                <a:latin typeface="Courier New" panose="02070309020205020404" pitchFamily="49" charset="0"/>
+                <a:cs typeface="Courier New" panose="02070309020205020404" pitchFamily="49" charset="0"/>
+              </a:rPr>
+              <a:t>32764</a:t>
+            </a:r>
+            <a:endParaRPr lang="de-DE" dirty="0">
+              <a:latin typeface="Courier New" panose="02070309020205020404" pitchFamily="49" charset="0"/>
+              <a:cs typeface="Courier New" panose="02070309020205020404" pitchFamily="49" charset="0"/>
+            </a:endParaRPr>
           </a:p>
           <a:p>
             <a:endParaRPr lang="de-DE" dirty="0">

</xml_diff>